<commit_message>
data-eng — MySQL 9.7(LTS) 기준 슬라이드 9덱 · 부록 PDF 다시 굽기
Co-Authored-By: Claude Opus 5.5 <noreply@anthropic.com>
</commit_message>
<xml_diff>
--- a/data-eng/decks/w1d5s4.pptx
+++ b/data-eng/decks/w1d5s4.pptx
@@ -3100,7 +3100,7 @@
       <p:grpSpPr/>
       <p:sp>
         <p:nvSpPr>
-          <p:cNvPr id="2" name="Oval 1"/>
+          <p:cNvPr id="2" name="deckgen:decor"/>
           <p:cNvSpPr/>
           <p:nvPr/>
         </p:nvSpPr>
@@ -3130,7 +3130,7 @@
       </p:sp>
       <p:sp>
         <p:nvSpPr>
-          <p:cNvPr id="3" name="Oval 2"/>
+          <p:cNvPr id="3" name="deckgen:decor"/>
           <p:cNvSpPr/>
           <p:nvPr/>
         </p:nvSpPr>
@@ -3160,7 +3160,7 @@
       </p:sp>
       <p:sp>
         <p:nvSpPr>
-          <p:cNvPr id="4" name="Oval 3"/>
+          <p:cNvPr id="4" name="deckgen:decor"/>
           <p:cNvSpPr/>
           <p:nvPr/>
         </p:nvSpPr>
@@ -3190,7 +3190,7 @@
       </p:sp>
       <p:sp>
         <p:nvSpPr>
-          <p:cNvPr id="5" name="Rectangle 4"/>
+          <p:cNvPr id="5" name="deckgen:decor"/>
           <p:cNvSpPr/>
           <p:nvPr/>
         </p:nvSpPr>
@@ -3220,7 +3220,7 @@
       </p:sp>
       <p:sp>
         <p:nvSpPr>
-          <p:cNvPr id="6" name="Oval 5"/>
+          <p:cNvPr id="6" name="deckgen:decor"/>
           <p:cNvSpPr/>
           <p:nvPr/>
         </p:nvSpPr>
@@ -3250,7 +3250,7 @@
       </p:sp>
       <p:sp>
         <p:nvSpPr>
-          <p:cNvPr id="7" name="Oval 6"/>
+          <p:cNvPr id="7" name="deckgen:decor"/>
           <p:cNvSpPr/>
           <p:nvPr/>
         </p:nvSpPr>
@@ -3280,7 +3280,7 @@
       </p:sp>
       <p:sp>
         <p:nvSpPr>
-          <p:cNvPr id="8" name="Oval 7"/>
+          <p:cNvPr id="8" name="deckgen:decor"/>
           <p:cNvSpPr/>
           <p:nvPr/>
         </p:nvSpPr>
@@ -3310,7 +3310,7 @@
       </p:sp>
       <p:sp>
         <p:nvSpPr>
-          <p:cNvPr id="9" name="Oval 8"/>
+          <p:cNvPr id="9" name="deckgen:decor"/>
           <p:cNvSpPr/>
           <p:nvPr/>
         </p:nvSpPr>
@@ -3340,7 +3340,7 @@
       </p:sp>
       <p:sp>
         <p:nvSpPr>
-          <p:cNvPr id="10" name="Rectangle 9"/>
+          <p:cNvPr id="10" name="deckgen:decor"/>
           <p:cNvSpPr/>
           <p:nvPr/>
         </p:nvSpPr>
@@ -3618,7 +3618,7 @@
       <p:grpSpPr/>
       <p:sp>
         <p:nvSpPr>
-          <p:cNvPr id="2" name="Oval 1"/>
+          <p:cNvPr id="2" name="deckgen:decor"/>
           <p:cNvSpPr/>
           <p:nvPr/>
         </p:nvSpPr>
@@ -3648,7 +3648,7 @@
       </p:sp>
       <p:sp>
         <p:nvSpPr>
-          <p:cNvPr id="3" name="Oval 2"/>
+          <p:cNvPr id="3" name="deckgen:decor"/>
           <p:cNvSpPr/>
           <p:nvPr/>
         </p:nvSpPr>
@@ -3678,7 +3678,7 @@
       </p:sp>
       <p:sp>
         <p:nvSpPr>
-          <p:cNvPr id="4" name="Oval 3"/>
+          <p:cNvPr id="4" name="deckgen:decor"/>
           <p:cNvSpPr/>
           <p:nvPr/>
         </p:nvSpPr>
@@ -3783,7 +3783,7 @@
                 <a:ea typeface="Pretendard"/>
                 <a:cs typeface="Pretendard"/>
               </a:rPr>
-              <a:t>2-1 · MySQL 8.0 설치 및 기초 쿼리 (4H)</a:t>
+              <a:t>2-1 · MySQL 9.7 설치 및 기초 쿼리 (4H)</a:t>
             </a:r>
           </a:p>
         </p:txBody>
@@ -3884,7 +3884,7 @@
       </p:sp>
       <p:sp>
         <p:nvSpPr>
-          <p:cNvPr id="10" name="TextBox 9"/>
+          <p:cNvPr id="10" name="deckgen:ornament"/>
           <p:cNvSpPr txBox="1"/>
           <p:nvPr/>
         </p:nvSpPr>
@@ -3980,7 +3980,7 @@
                 <a:ea typeface="Pretendard"/>
                 <a:cs typeface="Pretendard"/>
               </a:rPr>
-              <a:t>관계형 DB · MySQL 8.0</a:t>
+              <a:t>관계형 DB · MySQL 9.7</a:t>
             </a:r>
           </a:p>
           <a:p>
@@ -4069,7 +4069,7 @@
       </p:sp>
       <p:sp>
         <p:nvSpPr>
-          <p:cNvPr id="14" name="TextBox 13"/>
+          <p:cNvPr id="14" name="deckgen:ornament"/>
           <p:cNvSpPr txBox="1"/>
           <p:nvPr/>
         </p:nvSpPr>
@@ -4254,7 +4254,7 @@
       </p:sp>
       <p:sp>
         <p:nvSpPr>
-          <p:cNvPr id="18" name="TextBox 17"/>
+          <p:cNvPr id="18" name="deckgen:ornament"/>
           <p:cNvSpPr txBox="1"/>
           <p:nvPr/>
         </p:nvSpPr>
@@ -4439,7 +4439,7 @@
       </p:sp>
       <p:sp>
         <p:nvSpPr>
-          <p:cNvPr id="22" name="TextBox 21"/>
+          <p:cNvPr id="22" name="deckgen:ornament"/>
           <p:cNvSpPr txBox="1"/>
           <p:nvPr/>
         </p:nvSpPr>
@@ -4761,7 +4761,7 @@
       <p:grpSpPr/>
       <p:sp>
         <p:nvSpPr>
-          <p:cNvPr id="2" name="Oval 1"/>
+          <p:cNvPr id="2" name="deckgen:decor"/>
           <p:cNvSpPr/>
           <p:nvPr/>
         </p:nvSpPr>
@@ -4791,7 +4791,7 @@
       </p:sp>
       <p:sp>
         <p:nvSpPr>
-          <p:cNvPr id="3" name="Oval 2"/>
+          <p:cNvPr id="3" name="deckgen:decor"/>
           <p:cNvSpPr/>
           <p:nvPr/>
         </p:nvSpPr>
@@ -4926,7 +4926,7 @@
                 <a:ea typeface="Pretendard"/>
                 <a:cs typeface="Pretendard"/>
               </a:rPr>
-              <a:t>1주차 마무리 — 다음은 2-1 MySQL 8.0</a:t>
+              <a:t>1주차 마무리 — 다음은 2-1 MySQL 9.7</a:t>
             </a:r>
           </a:p>
         </p:txBody>
@@ -5543,7 +5543,7 @@
                 <a:ea typeface="Pretendard"/>
                 <a:cs typeface="Pretendard"/>
               </a:rPr>
-              <a:t>2-1 MySQL 8.0 설치 및 기초 쿼리</a:t>
+              <a:t>2-1 MySQL 9.7 설치 및 기초 쿼리</a:t>
             </a:r>
           </a:p>
         </p:txBody>
@@ -5568,7 +5568,7 @@
       <p:grpSpPr/>
       <p:sp>
         <p:nvSpPr>
-          <p:cNvPr id="2" name="Oval 1"/>
+          <p:cNvPr id="2" name="deckgen:decor"/>
           <p:cNvSpPr/>
           <p:nvPr/>
         </p:nvSpPr>
@@ -5598,7 +5598,7 @@
       </p:sp>
       <p:sp>
         <p:nvSpPr>
-          <p:cNvPr id="3" name="Oval 2"/>
+          <p:cNvPr id="3" name="deckgen:decor"/>
           <p:cNvSpPr/>
           <p:nvPr/>
         </p:nvSpPr>
@@ -5628,7 +5628,7 @@
       </p:sp>
       <p:sp>
         <p:nvSpPr>
-          <p:cNvPr id="4" name="Oval 3"/>
+          <p:cNvPr id="4" name="deckgen:decor"/>
           <p:cNvSpPr/>
           <p:nvPr/>
         </p:nvSpPr>
@@ -6559,7 +6559,7 @@
       <p:grpSpPr/>
       <p:sp>
         <p:nvSpPr>
-          <p:cNvPr id="2" name="Oval 1"/>
+          <p:cNvPr id="2" name="deckgen:decor"/>
           <p:cNvSpPr/>
           <p:nvPr/>
         </p:nvSpPr>
@@ -6589,7 +6589,7 @@
       </p:sp>
       <p:sp>
         <p:nvSpPr>
-          <p:cNvPr id="3" name="Oval 2"/>
+          <p:cNvPr id="3" name="deckgen:decor"/>
           <p:cNvSpPr/>
           <p:nvPr/>
         </p:nvSpPr>
@@ -6619,7 +6619,7 @@
       </p:sp>
       <p:sp>
         <p:nvSpPr>
-          <p:cNvPr id="4" name="Oval 3"/>
+          <p:cNvPr id="4" name="deckgen:decor"/>
           <p:cNvSpPr/>
           <p:nvPr/>
         </p:nvSpPr>
@@ -8270,7 +8270,7 @@
       <p:grpSpPr/>
       <p:sp>
         <p:nvSpPr>
-          <p:cNvPr id="2" name="Oval 1"/>
+          <p:cNvPr id="2" name="deckgen:decor"/>
           <p:cNvSpPr/>
           <p:nvPr/>
         </p:nvSpPr>
@@ -8300,7 +8300,7 @@
       </p:sp>
       <p:sp>
         <p:nvSpPr>
-          <p:cNvPr id="3" name="Oval 2"/>
+          <p:cNvPr id="3" name="deckgen:decor"/>
           <p:cNvSpPr/>
           <p:nvPr/>
         </p:nvSpPr>
@@ -8330,7 +8330,7 @@
       </p:sp>
       <p:sp>
         <p:nvSpPr>
-          <p:cNvPr id="4" name="Oval 3"/>
+          <p:cNvPr id="4" name="deckgen:decor"/>
           <p:cNvSpPr/>
           <p:nvPr/>
         </p:nvSpPr>
@@ -9535,7 +9535,7 @@
       <p:grpSpPr/>
       <p:sp>
         <p:nvSpPr>
-          <p:cNvPr id="2" name="Oval 1"/>
+          <p:cNvPr id="2" name="deckgen:decor"/>
           <p:cNvSpPr/>
           <p:nvPr/>
         </p:nvSpPr>
@@ -9565,7 +9565,7 @@
       </p:sp>
       <p:sp>
         <p:nvSpPr>
-          <p:cNvPr id="3" name="Oval 2"/>
+          <p:cNvPr id="3" name="deckgen:decor"/>
           <p:cNvSpPr/>
           <p:nvPr/>
         </p:nvSpPr>
@@ -9595,7 +9595,7 @@
       </p:sp>
       <p:sp>
         <p:nvSpPr>
-          <p:cNvPr id="4" name="Oval 3"/>
+          <p:cNvPr id="4" name="deckgen:decor"/>
           <p:cNvSpPr/>
           <p:nvPr/>
         </p:nvSpPr>
@@ -11250,7 +11250,7 @@
       <p:grpSpPr/>
       <p:sp>
         <p:nvSpPr>
-          <p:cNvPr id="2" name="Oval 1"/>
+          <p:cNvPr id="2" name="deckgen:decor"/>
           <p:cNvSpPr/>
           <p:nvPr/>
         </p:nvSpPr>
@@ -11280,7 +11280,7 @@
       </p:sp>
       <p:sp>
         <p:nvSpPr>
-          <p:cNvPr id="3" name="Oval 2"/>
+          <p:cNvPr id="3" name="deckgen:decor"/>
           <p:cNvSpPr/>
           <p:nvPr/>
         </p:nvSpPr>
@@ -11310,7 +11310,7 @@
       </p:sp>
       <p:sp>
         <p:nvSpPr>
-          <p:cNvPr id="4" name="Oval 3"/>
+          <p:cNvPr id="4" name="deckgen:decor"/>
           <p:cNvSpPr/>
           <p:nvPr/>
         </p:nvSpPr>
@@ -12441,7 +12441,7 @@
       <p:grpSpPr/>
       <p:sp>
         <p:nvSpPr>
-          <p:cNvPr id="2" name="Oval 1"/>
+          <p:cNvPr id="2" name="deckgen:decor"/>
           <p:cNvSpPr/>
           <p:nvPr/>
         </p:nvSpPr>
@@ -12471,7 +12471,7 @@
       </p:sp>
       <p:sp>
         <p:nvSpPr>
-          <p:cNvPr id="3" name="Oval 2"/>
+          <p:cNvPr id="3" name="deckgen:decor"/>
           <p:cNvSpPr/>
           <p:nvPr/>
         </p:nvSpPr>
@@ -12501,7 +12501,7 @@
       </p:sp>
       <p:sp>
         <p:nvSpPr>
-          <p:cNvPr id="4" name="Oval 3"/>
+          <p:cNvPr id="4" name="deckgen:decor"/>
           <p:cNvSpPr/>
           <p:nvPr/>
         </p:nvSpPr>
@@ -13941,7 +13941,7 @@
       <p:grpSpPr/>
       <p:sp>
         <p:nvSpPr>
-          <p:cNvPr id="2" name="Oval 1"/>
+          <p:cNvPr id="2" name="deckgen:decor"/>
           <p:cNvSpPr/>
           <p:nvPr/>
         </p:nvSpPr>
@@ -13971,7 +13971,7 @@
       </p:sp>
       <p:sp>
         <p:nvSpPr>
-          <p:cNvPr id="3" name="Oval 2"/>
+          <p:cNvPr id="3" name="deckgen:decor"/>
           <p:cNvSpPr/>
           <p:nvPr/>
         </p:nvSpPr>
@@ -14001,7 +14001,7 @@
       </p:sp>
       <p:sp>
         <p:nvSpPr>
-          <p:cNvPr id="4" name="Oval 3"/>
+          <p:cNvPr id="4" name="deckgen:decor"/>
           <p:cNvSpPr/>
           <p:nvPr/>
         </p:nvSpPr>
@@ -15202,7 +15202,7 @@
       <p:grpSpPr/>
       <p:sp>
         <p:nvSpPr>
-          <p:cNvPr id="2" name="Oval 1"/>
+          <p:cNvPr id="2" name="deckgen:decor"/>
           <p:cNvSpPr/>
           <p:nvPr/>
         </p:nvSpPr>
@@ -15232,7 +15232,7 @@
       </p:sp>
       <p:sp>
         <p:nvSpPr>
-          <p:cNvPr id="3" name="Oval 2"/>
+          <p:cNvPr id="3" name="deckgen:decor"/>
           <p:cNvSpPr/>
           <p:nvPr/>
         </p:nvSpPr>
@@ -15262,7 +15262,7 @@
       </p:sp>
       <p:sp>
         <p:nvSpPr>
-          <p:cNvPr id="4" name="Oval 3"/>
+          <p:cNvPr id="4" name="deckgen:decor"/>
           <p:cNvSpPr/>
           <p:nvPr/>
         </p:nvSpPr>

</xml_diff>